<commit_message>
feat: dashboard metrics strip + expanded 10-slide PPTX
- Metrics strip: AUM, alerts, conflicts, DNA traits at a glance
- PPTX: added Technology Stack, Trust & Explainability, Client Personas slides
- Updated Demo slide to "Live Demo" with walkthrough list
- 10/10 E2E pass, PPTX 109KB

Co-Authored-By: Claude Opus 4.6 (1M context) <noreply@anthropic.com>
</commit_message>
<xml_diff>
--- a/output/presentation.pptx
+++ b/output/presentation.pptx
@@ -12,9 +12,12 @@
     <p:sldId id="260" r:id="rId6"/>
     <p:sldId id="261" r:id="rId7"/>
     <p:sldId id="262" r:id="rId8"/>
+    <p:sldId id="263" r:id="rId9"/>
+    <p:sldId id="264" r:id="rId10"/>
+    <p:sldId id="265" r:id="rId11"/>
   </p:sldIdLst>
   <p:notesMasterIdLst>
-    <p:notesMasterId r:id="rId9"/>
+    <p:notesMasterId r:id="rId12"/>
   </p:notesMasterIdLst>
   <p:sldSz cx="9144000" cy="5143500"/>
   <p:notesSz cx="5143500" cy="9144000"/>
@@ -550,6 +553,94 @@
 </p:notes>
 </file>
 
+<file path=ppt/notesSlides/notesSlide10.xml><?xml version="1.0" encoding="utf-8"?>
+<p:notes xmlns:a="http://schemas.openxmlformats.org/drawingml/2006/main" xmlns:r="http://schemas.openxmlformats.org/officeDocument/2006/relationships" xmlns:p="http://schemas.openxmlformats.org/presentationml/2006/main">
+  <p:cSld>
+    <p:spTree>
+      <p:nvGrpSpPr>
+        <p:cNvPr id="1" name=""/>
+        <p:cNvGrpSpPr/>
+        <p:nvPr/>
+      </p:nvGrpSpPr>
+      <p:grpSpPr>
+        <a:xfrm>
+          <a:off x="0" y="0"/>
+          <a:ext cx="0" cy="0"/>
+          <a:chOff x="0" y="0"/>
+          <a:chExt cx="0" cy="0"/>
+        </a:xfrm>
+      </p:grpSpPr>
+      <p:sp>
+        <p:nvSpPr>
+          <p:cNvPr id="2" name="Slide Image Placeholder 1"/>
+          <p:cNvSpPr>
+            <a:spLocks noGrp="1" noRot="1" noChangeAspect="1"/>
+          </p:cNvSpPr>
+          <p:nvPr>
+            <p:ph type="sldImg"/>
+          </p:nvPr>
+        </p:nvSpPr>
+        <p:spPr/>
+      </p:sp>
+      <p:sp>
+        <p:nvSpPr>
+          <p:cNvPr id="3" name="Notes Placeholder 2"/>
+          <p:cNvSpPr>
+            <a:spLocks noGrp="1"/>
+          </p:cNvSpPr>
+          <p:nvPr>
+            <p:ph type="body" idx="1"/>
+          </p:nvPr>
+        </p:nvSpPr>
+        <p:spPr/>
+        <p:txBody>
+          <a:bodyPr/>
+          <a:lstStyle/>
+          <a:p>
+            <a:r>
+              <a:rPr lang="en-US" dirty="0"/>
+              <a:t/>
+            </a:r>
+            <a:endParaRPr lang="en-US" dirty="0"/>
+          </a:p>
+        </p:txBody>
+      </p:sp>
+      <p:sp>
+        <p:nvSpPr>
+          <p:cNvPr id="4" name="Slide Number Placeholder 3"/>
+          <p:cNvSpPr>
+            <a:spLocks noGrp="1"/>
+          </p:cNvSpPr>
+          <p:nvPr>
+            <p:ph type="sldNum" sz="quarter" idx="10"/>
+          </p:nvPr>
+        </p:nvSpPr>
+        <p:spPr/>
+        <p:txBody>
+          <a:bodyPr/>
+          <a:lstStyle/>
+          <a:p>
+            <a:fld id="{F7021451-1387-4CA6-816F-3879F97B5CBC}" type="slidenum">
+              <a:rPr lang="en-US"/>
+              <a:t>10</a:t>
+            </a:fld>
+            <a:endParaRPr lang="en-US"/>
+          </a:p>
+        </p:txBody>
+      </p:sp>
+    </p:spTree>
+    <p:extLst>
+      <p:ext uri="{BB962C8B-B14F-4D97-AF65-F5344CB8AC3E}">
+        <p14:creationId xmlns:p14="http://schemas.microsoft.com/office/powerpoint/2010/main" val="1024086991"/>
+      </p:ext>
+    </p:extLst>
+  </p:cSld>
+  <p:clrMapOvr>
+    <a:masterClrMapping/>
+  </p:clrMapOvr>
+</p:notes>
+</file>
+
 <file path=ppt/notesSlides/notesSlide2.xml><?xml version="1.0" encoding="utf-8"?>
 <p:notes xmlns:a="http://schemas.openxmlformats.org/drawingml/2006/main" xmlns:r="http://schemas.openxmlformats.org/officeDocument/2006/relationships" xmlns:p="http://schemas.openxmlformats.org/presentationml/2006/main">
   <p:cSld>
@@ -1060,6 +1151,182 @@
             <a:fld id="{F7021451-1387-4CA6-816F-3879F97B5CBC}" type="slidenum">
               <a:rPr lang="en-US"/>
               <a:t>7</a:t>
+            </a:fld>
+            <a:endParaRPr lang="en-US"/>
+          </a:p>
+        </p:txBody>
+      </p:sp>
+    </p:spTree>
+    <p:extLst>
+      <p:ext uri="{BB962C8B-B14F-4D97-AF65-F5344CB8AC3E}">
+        <p14:creationId xmlns:p14="http://schemas.microsoft.com/office/powerpoint/2010/main" val="1024086991"/>
+      </p:ext>
+    </p:extLst>
+  </p:cSld>
+  <p:clrMapOvr>
+    <a:masterClrMapping/>
+  </p:clrMapOvr>
+</p:notes>
+</file>
+
+<file path=ppt/notesSlides/notesSlide8.xml><?xml version="1.0" encoding="utf-8"?>
+<p:notes xmlns:a="http://schemas.openxmlformats.org/drawingml/2006/main" xmlns:r="http://schemas.openxmlformats.org/officeDocument/2006/relationships" xmlns:p="http://schemas.openxmlformats.org/presentationml/2006/main">
+  <p:cSld>
+    <p:spTree>
+      <p:nvGrpSpPr>
+        <p:cNvPr id="1" name=""/>
+        <p:cNvGrpSpPr/>
+        <p:nvPr/>
+      </p:nvGrpSpPr>
+      <p:grpSpPr>
+        <a:xfrm>
+          <a:off x="0" y="0"/>
+          <a:ext cx="0" cy="0"/>
+          <a:chOff x="0" y="0"/>
+          <a:chExt cx="0" cy="0"/>
+        </a:xfrm>
+      </p:grpSpPr>
+      <p:sp>
+        <p:nvSpPr>
+          <p:cNvPr id="2" name="Slide Image Placeholder 1"/>
+          <p:cNvSpPr>
+            <a:spLocks noGrp="1" noRot="1" noChangeAspect="1"/>
+          </p:cNvSpPr>
+          <p:nvPr>
+            <p:ph type="sldImg"/>
+          </p:nvPr>
+        </p:nvSpPr>
+        <p:spPr/>
+      </p:sp>
+      <p:sp>
+        <p:nvSpPr>
+          <p:cNvPr id="3" name="Notes Placeholder 2"/>
+          <p:cNvSpPr>
+            <a:spLocks noGrp="1"/>
+          </p:cNvSpPr>
+          <p:nvPr>
+            <p:ph type="body" idx="1"/>
+          </p:nvPr>
+        </p:nvSpPr>
+        <p:spPr/>
+        <p:txBody>
+          <a:bodyPr/>
+          <a:lstStyle/>
+          <a:p>
+            <a:r>
+              <a:rPr lang="en-US" dirty="0"/>
+              <a:t/>
+            </a:r>
+            <a:endParaRPr lang="en-US" dirty="0"/>
+          </a:p>
+        </p:txBody>
+      </p:sp>
+      <p:sp>
+        <p:nvSpPr>
+          <p:cNvPr id="4" name="Slide Number Placeholder 3"/>
+          <p:cNvSpPr>
+            <a:spLocks noGrp="1"/>
+          </p:cNvSpPr>
+          <p:nvPr>
+            <p:ph type="sldNum" sz="quarter" idx="10"/>
+          </p:nvPr>
+        </p:nvSpPr>
+        <p:spPr/>
+        <p:txBody>
+          <a:bodyPr/>
+          <a:lstStyle/>
+          <a:p>
+            <a:fld id="{F7021451-1387-4CA6-816F-3879F97B5CBC}" type="slidenum">
+              <a:rPr lang="en-US"/>
+              <a:t>8</a:t>
+            </a:fld>
+            <a:endParaRPr lang="en-US"/>
+          </a:p>
+        </p:txBody>
+      </p:sp>
+    </p:spTree>
+    <p:extLst>
+      <p:ext uri="{BB962C8B-B14F-4D97-AF65-F5344CB8AC3E}">
+        <p14:creationId xmlns:p14="http://schemas.microsoft.com/office/powerpoint/2010/main" val="1024086991"/>
+      </p:ext>
+    </p:extLst>
+  </p:cSld>
+  <p:clrMapOvr>
+    <a:masterClrMapping/>
+  </p:clrMapOvr>
+</p:notes>
+</file>
+
+<file path=ppt/notesSlides/notesSlide9.xml><?xml version="1.0" encoding="utf-8"?>
+<p:notes xmlns:a="http://schemas.openxmlformats.org/drawingml/2006/main" xmlns:r="http://schemas.openxmlformats.org/officeDocument/2006/relationships" xmlns:p="http://schemas.openxmlformats.org/presentationml/2006/main">
+  <p:cSld>
+    <p:spTree>
+      <p:nvGrpSpPr>
+        <p:cNvPr id="1" name=""/>
+        <p:cNvGrpSpPr/>
+        <p:nvPr/>
+      </p:nvGrpSpPr>
+      <p:grpSpPr>
+        <a:xfrm>
+          <a:off x="0" y="0"/>
+          <a:ext cx="0" cy="0"/>
+          <a:chOff x="0" y="0"/>
+          <a:chExt cx="0" cy="0"/>
+        </a:xfrm>
+      </p:grpSpPr>
+      <p:sp>
+        <p:nvSpPr>
+          <p:cNvPr id="2" name="Slide Image Placeholder 1"/>
+          <p:cNvSpPr>
+            <a:spLocks noGrp="1" noRot="1" noChangeAspect="1"/>
+          </p:cNvSpPr>
+          <p:nvPr>
+            <p:ph type="sldImg"/>
+          </p:nvPr>
+        </p:nvSpPr>
+        <p:spPr/>
+      </p:sp>
+      <p:sp>
+        <p:nvSpPr>
+          <p:cNvPr id="3" name="Notes Placeholder 2"/>
+          <p:cNvSpPr>
+            <a:spLocks noGrp="1"/>
+          </p:cNvSpPr>
+          <p:nvPr>
+            <p:ph type="body" idx="1"/>
+          </p:nvPr>
+        </p:nvSpPr>
+        <p:spPr/>
+        <p:txBody>
+          <a:bodyPr/>
+          <a:lstStyle/>
+          <a:p>
+            <a:r>
+              <a:rPr lang="en-US" dirty="0"/>
+              <a:t/>
+            </a:r>
+            <a:endParaRPr lang="en-US" dirty="0"/>
+          </a:p>
+        </p:txBody>
+      </p:sp>
+      <p:sp>
+        <p:nvSpPr>
+          <p:cNvPr id="4" name="Slide Number Placeholder 3"/>
+          <p:cNvSpPr>
+            <a:spLocks noGrp="1"/>
+          </p:cNvSpPr>
+          <p:nvPr>
+            <p:ph type="sldNum" sz="quarter" idx="10"/>
+          </p:nvPr>
+        </p:nvSpPr>
+        <p:spPr/>
+        <p:txBody>
+          <a:bodyPr/>
+          <a:lstStyle/>
+          <a:p>
+            <a:fld id="{F7021451-1387-4CA6-816F-3879F97B5CBC}" type="slidenum">
+              <a:rPr lang="en-US"/>
+              <a:t>9</a:t>
             </a:fld>
             <a:endParaRPr lang="en-US"/>
           </a:p>
@@ -1525,6 +1792,110 @@
 </p:sld>
 </file>
 
+<file path=ppt/slides/slide10.xml><?xml version="1.0" encoding="utf-8"?>
+<p:sld xmlns:a="http://schemas.openxmlformats.org/drawingml/2006/main" xmlns:r="http://schemas.openxmlformats.org/officeDocument/2006/relationships" xmlns:p="http://schemas.openxmlformats.org/presentationml/2006/main">
+  <p:cSld name="Slide 10">
+    <p:bg>
+      <p:bgPr>
+        <a:solidFill>
+          <a:srgbClr val="0F172A"/>
+        </a:solidFill>
+      </p:bgPr>
+    </p:bg>
+    <p:spTree>
+      <p:nvGrpSpPr>
+        <p:cNvPr id="1" name=""/>
+        <p:cNvGrpSpPr/>
+        <p:nvPr/>
+      </p:nvGrpSpPr>
+      <p:grpSpPr>
+        <a:xfrm>
+          <a:off x="0" y="0"/>
+          <a:ext cx="0" cy="0"/>
+          <a:chOff x="0" y="0"/>
+          <a:chExt cx="0" cy="0"/>
+        </a:xfrm>
+      </p:grpSpPr>
+      <p:sp>
+        <p:nvSpPr>
+          <p:cNvPr id="2" name="Text 0"/>
+          <p:cNvSpPr/>
+          <p:nvPr/>
+        </p:nvSpPr>
+        <p:spPr>
+          <a:xfrm>
+            <a:off x="457200" y="457200"/>
+            <a:ext cx="8229600" cy="731520"/>
+          </a:xfrm>
+          <a:prstGeom prst="rect">
+            <a:avLst/>
+          </a:prstGeom>
+          <a:noFill/>
+          <a:ln/>
+        </p:spPr>
+        <p:txBody>
+          <a:bodyPr wrap="square" rtlCol="0" anchor="ctr"/>
+          <a:lstStyle/>
+          <a:p>
+            <a:pPr indent="0" marL="0">
+              <a:buNone/>
+            </a:pPr>
+            <a:r>
+              <a:rPr lang="en-US" sz="2800" b="1" dirty="0">
+                <a:solidFill>
+                  <a:srgbClr val="FFFFFF"/>
+                </a:solidFill>
+              </a:rPr>
+              <a:t>Team</a:t>
+            </a:r>
+            <a:endParaRPr lang="en-US" sz="2800" dirty="0"/>
+          </a:p>
+        </p:txBody>
+      </p:sp>
+      <p:sp>
+        <p:nvSpPr>
+          <p:cNvPr id="3" name="Text 1"/>
+          <p:cNvSpPr/>
+          <p:nvPr/>
+        </p:nvSpPr>
+        <p:spPr>
+          <a:xfrm>
+            <a:off x="914400" y="2286000"/>
+            <a:ext cx="7315200" cy="914400"/>
+          </a:xfrm>
+          <a:prstGeom prst="rect">
+            <a:avLst/>
+          </a:prstGeom>
+          <a:noFill/>
+          <a:ln/>
+        </p:spPr>
+        <p:txBody>
+          <a:bodyPr wrap="square" rtlCol="0" anchor="ctr"/>
+          <a:lstStyle/>
+          <a:p>
+            <a:pPr algn="ctr" indent="0" marL="0">
+              <a:buNone/>
+            </a:pPr>
+            <a:r>
+              <a:rPr lang="en-US" sz="1600" i="1" dirty="0">
+                <a:solidFill>
+                  <a:srgbClr val="64748B"/>
+                </a:solidFill>
+              </a:rPr>
+              <a:t>[Team members here]</a:t>
+            </a:r>
+            <a:endParaRPr lang="en-US" sz="1600" dirty="0"/>
+          </a:p>
+        </p:txBody>
+      </p:sp>
+    </p:spTree>
+  </p:cSld>
+  <p:clrMapOvr>
+    <a:masterClrMapping/>
+  </p:clrMapOvr>
+</p:sld>
+</file>
+
 <file path=ppt/slides/slide2.xml><?xml version="1.0" encoding="utf-8"?>
 <p:sld xmlns:a="http://schemas.openxmlformats.org/drawingml/2006/main" xmlns:r="http://schemas.openxmlformats.org/officeDocument/2006/relationships" xmlns:p="http://schemas.openxmlformats.org/presentationml/2006/main">
   <p:cSld name="Slide 2">
@@ -2050,7 +2421,7 @@
                   <a:srgbClr val="FFFFFF"/>
                 </a:solidFill>
               </a:rPr>
-              <a:t>Live Demo</a:t>
+              <a:t>Technology Stack</a:t>
             </a:r>
             <a:endParaRPr lang="en-US" sz="2800" dirty="0"/>
           </a:p>
@@ -2064,8 +2435,8 @@
         </p:nvSpPr>
         <p:spPr>
           <a:xfrm>
-            <a:off x="914400" y="2286000"/>
-            <a:ext cx="7315200" cy="914400"/>
+            <a:off x="457200" y="1371600"/>
+            <a:ext cx="8229600" cy="3657600"/>
           </a:xfrm>
           <a:prstGeom prst="rect">
             <a:avLst/>
@@ -2077,18 +2448,122 @@
           <a:bodyPr wrap="square" rtlCol="0" anchor="ctr"/>
           <a:lstStyle/>
           <a:p>
-            <a:pPr algn="ctr" indent="0" marL="0">
-              <a:buNone/>
-            </a:pPr>
-            <a:r>
-              <a:rPr lang="en-US" sz="1600" i="1" dirty="0">
-                <a:solidFill>
-                  <a:srgbClr val="64748B"/>
-                </a:solidFill>
-              </a:rPr>
-              <a:t>[Insert screenshots from the dashboard here]</a:t>
-            </a:r>
-            <a:endParaRPr lang="en-US" sz="1600" dirty="0"/>
+            <a:pPr indent="0" marL="0">
+              <a:buNone/>
+            </a:pPr>
+            <a:r>
+              <a:rPr lang="en-US" sz="1400" b="1" dirty="0">
+                <a:solidFill>
+                  <a:srgbClr val="2DD4BF"/>
+                </a:solidFill>
+              </a:rPr>
+              <a:t>• SIX Financial Information MCP</a:t>
+            </a:r>
+            <a:pPr indent="0" marL="0">
+              <a:buNone/>
+            </a:pPr>
+            <a:r>
+              <a:rPr lang="en-US" sz="1400" dirty="0">
+                <a:solidFill>
+                  <a:srgbClr val="94A3B8"/>
+                </a:solidFill>
+              </a:rPr>
+              <a:t> — real-time market data, instrument enrichment and pricing
+</a:t>
+            </a:r>
+            <a:pPr indent="0" marL="0">
+              <a:buNone/>
+            </a:pPr>
+            <a:r>
+              <a:rPr lang="en-US" sz="1400" b="1" dirty="0">
+                <a:solidFill>
+                  <a:srgbClr val="2DD4BF"/>
+                </a:solidFill>
+              </a:rPr>
+              <a:t>• Event Registry</a:t>
+            </a:r>
+            <a:pPr indent="0" marL="0">
+              <a:buNone/>
+            </a:pPr>
+            <a:r>
+              <a:rPr lang="en-US" sz="1400" dirty="0">
+                <a:solidFill>
+                  <a:srgbClr val="94A3B8"/>
+                </a:solidFill>
+              </a:rPr>
+              <a:t> — live global news monitoring with per-client relevance scoring
+</a:t>
+            </a:r>
+            <a:pPr indent="0" marL="0">
+              <a:buNone/>
+            </a:pPr>
+            <a:r>
+              <a:rPr lang="en-US" sz="1400" b="1" dirty="0">
+                <a:solidFill>
+                  <a:srgbClr val="2DD4BF"/>
+                </a:solidFill>
+              </a:rPr>
+              <a:t>• Phoeniqs LLM</a:t>
+            </a:r>
+            <a:pPr indent="0" marL="0">
+              <a:buNone/>
+            </a:pPr>
+            <a:r>
+              <a:rPr lang="en-US" sz="1400" dirty="0">
+                <a:solidFill>
+                  <a:srgbClr val="94A3B8"/>
+                </a:solidFill>
+              </a:rPr>
+              <a:t> — AI-powered analysis and personalised narrative generation
+</a:t>
+            </a:r>
+            <a:pPr indent="0" marL="0">
+              <a:buNone/>
+            </a:pPr>
+            <a:r>
+              <a:rPr lang="en-US" sz="1400" b="1" dirty="0">
+                <a:solidFill>
+                  <a:srgbClr val="2DD4BF"/>
+                </a:solidFill>
+              </a:rPr>
+              <a:t>• Noumena Digital</a:t>
+            </a:r>
+            <a:pPr indent="0" marL="0">
+              <a:buNone/>
+            </a:pPr>
+            <a:r>
+              <a:rPr lang="en-US" sz="1400" dirty="0">
+                <a:solidFill>
+                  <a:srgbClr val="94A3B8"/>
+                </a:solidFill>
+              </a:rPr>
+              <a:t> — knowledge graph modelling for client DNA and portfolio relationships
+</a:t>
+            </a:r>
+            <a:pPr indent="0" marL="0">
+              <a:buNone/>
+            </a:pPr>
+            <a:r>
+              <a:rPr lang="en-US" sz="1400" b="1" dirty="0">
+                <a:solidFill>
+                  <a:srgbClr val="2DD4BF"/>
+                </a:solidFill>
+              </a:rPr>
+              <a:t>• NTT DATA</a:t>
+            </a:r>
+            <a:pPr indent="0" marL="0">
+              <a:buNone/>
+            </a:pPr>
+            <a:r>
+              <a:rPr lang="en-US" sz="1400" dirty="0">
+                <a:solidFill>
+                  <a:srgbClr val="94A3B8"/>
+                </a:solidFill>
+              </a:rPr>
+              <a:t> — explainable AI patterns, audit trails and enterprise-grade compliance
+</a:t>
+            </a:r>
+            <a:endParaRPr lang="en-US" sz="1400" dirty="0"/>
           </a:p>
         </p:txBody>
       </p:sp>
@@ -2154,7 +2629,7 @@
                   <a:srgbClr val="FFFFFF"/>
                 </a:solidFill>
               </a:rPr>
-              <a:t>Key Features</a:t>
+              <a:t>Live Demo</a:t>
             </a:r>
             <a:endParaRPr lang="en-US" sz="2800" dirty="0"/>
           </a:p>
@@ -2185,12 +2660,24 @@
               <a:buNone/>
             </a:pPr>
             <a:r>
+              <a:rPr lang="en-US" sz="1600" b="1" dirty="0">
+                <a:solidFill>
+                  <a:srgbClr val="E2E8F0"/>
+                </a:solidFill>
+              </a:rPr>
+              <a:t>What you will see:
+</a:t>
+            </a:r>
+            <a:pPr indent="0" marL="0">
+              <a:buNone/>
+            </a:pPr>
+            <a:r>
               <a:rPr lang="en-US" sz="1400" dirty="0">
                 <a:solidFill>
-                  <a:srgbClr val="E2E8F0"/>
-                </a:solidFill>
-              </a:rPr>
-              <a:t>✓ Client DNA Profiling — AI reads CRM logs, builds investment identity
+                  <a:srgbClr val="2DD4BF"/>
+                </a:solidFill>
+              </a:rPr>
+              <a:t>1. Client DNA extraction from CRM notes — live AI analysis
 </a:t>
             </a:r>
             <a:pPr indent="0" marL="0">
@@ -2199,10 +2686,10 @@
             <a:r>
               <a:rPr lang="en-US" sz="1400" dirty="0">
                 <a:solidFill>
-                  <a:srgbClr val="E2E8F0"/>
-                </a:solidFill>
-              </a:rPr>
-              <a:t>✓ Smart Alerts — news and CIO conflicts matched against client DNA
+                  <a:srgbClr val="2DD4BF"/>
+                </a:solidFill>
+              </a:rPr>
+              <a:t>2. Real-time news alert matched to a specific client's values
 </a:t>
             </a:r>
             <a:pPr indent="0" marL="0">
@@ -2211,10 +2698,10 @@
             <a:r>
               <a:rPr lang="en-US" sz="1400" dirty="0">
                 <a:solidFill>
-                  <a:srgbClr val="E2E8F0"/>
-                </a:solidFill>
-              </a:rPr>
-              <a:t>✓ DNA-Aware Swaps — replacements within mandate, BUY-rated by CIO
+                  <a:srgbClr val="2DD4BF"/>
+                </a:solidFill>
+              </a:rPr>
+              <a:t>3. Automated DNA-aware portfolio swap suggestion within mandate
 </a:t>
             </a:r>
             <a:pPr indent="0" marL="0">
@@ -2223,10 +2710,10 @@
             <a:r>
               <a:rPr lang="en-US" sz="1400" dirty="0">
                 <a:solidFill>
-                  <a:srgbClr val="E2E8F0"/>
-                </a:solidFill>
-              </a:rPr>
-              <a:t>✓ Tone-Matched Messages — data-driven or values-led, per client
+                  <a:srgbClr val="2DD4BF"/>
+                </a:solidFill>
+              </a:rPr>
+              <a:t>4. Tone-matched advisory message drafted for RM review
 </a:t>
             </a:r>
             <a:pPr indent="0" marL="0">
@@ -2235,10 +2722,10 @@
             <a:r>
               <a:rPr lang="en-US" sz="1400" dirty="0">
                 <a:solidFill>
-                  <a:srgbClr val="E2E8F0"/>
-                </a:solidFill>
-              </a:rPr>
-              <a:t>✓ Full Tracing — every AI decision logged with reasoning chain
+                  <a:srgbClr val="2DD4BF"/>
+                </a:solidFill>
+              </a:rPr>
+              <a:t>5. Full reasoning chain and source citations on every output
 </a:t>
             </a:r>
             <a:pPr indent="0" marL="0">
@@ -2247,13 +2734,13 @@
             <a:r>
               <a:rPr lang="en-US" sz="1400" dirty="0">
                 <a:solidFill>
-                  <a:srgbClr val="E2E8F0"/>
-                </a:solidFill>
-              </a:rPr>
-              <a:t>✓ Human-in-the-Loop — RM approves, client always decides
-</a:t>
-            </a:r>
-            <a:endParaRPr lang="en-US" sz="1400" dirty="0"/>
+                  <a:srgbClr val="2DD4BF"/>
+                </a:solidFill>
+              </a:rPr>
+              <a:t>6. RM approval flow — human-in-the-loop before anything reaches the client
+</a:t>
+            </a:r>
+            <a:endParaRPr lang="en-US" sz="1600" dirty="0"/>
           </a:p>
         </p:txBody>
       </p:sp>
@@ -2319,7 +2806,7 @@
                   <a:srgbClr val="FFFFFF"/>
                 </a:solidFill>
               </a:rPr>
-              <a:t>Team</a:t>
+              <a:t>Key Features</a:t>
             </a:r>
             <a:endParaRPr lang="en-US" sz="2800" dirty="0"/>
           </a:p>
@@ -2333,8 +2820,8 @@
         </p:nvSpPr>
         <p:spPr>
           <a:xfrm>
-            <a:off x="914400" y="2286000"/>
-            <a:ext cx="7315200" cy="914400"/>
+            <a:off x="457200" y="1371600"/>
+            <a:ext cx="8229600" cy="3657600"/>
           </a:xfrm>
           <a:prstGeom prst="rect">
             <a:avLst/>
@@ -2346,18 +2833,495 @@
           <a:bodyPr wrap="square" rtlCol="0" anchor="ctr"/>
           <a:lstStyle/>
           <a:p>
-            <a:pPr algn="ctr" indent="0" marL="0">
-              <a:buNone/>
-            </a:pPr>
-            <a:r>
-              <a:rPr lang="en-US" sz="1600" i="1" dirty="0">
-                <a:solidFill>
-                  <a:srgbClr val="64748B"/>
-                </a:solidFill>
-              </a:rPr>
-              <a:t>[Team members here]</a:t>
-            </a:r>
-            <a:endParaRPr lang="en-US" sz="1600" dirty="0"/>
+            <a:pPr indent="0" marL="0">
+              <a:buNone/>
+            </a:pPr>
+            <a:r>
+              <a:rPr lang="en-US" sz="1400" dirty="0">
+                <a:solidFill>
+                  <a:srgbClr val="E2E8F0"/>
+                </a:solidFill>
+              </a:rPr>
+              <a:t>✓ Client DNA Profiling — AI reads CRM logs, builds investment identity
+</a:t>
+            </a:r>
+            <a:pPr indent="0" marL="0">
+              <a:buNone/>
+            </a:pPr>
+            <a:r>
+              <a:rPr lang="en-US" sz="1400" dirty="0">
+                <a:solidFill>
+                  <a:srgbClr val="E2E8F0"/>
+                </a:solidFill>
+              </a:rPr>
+              <a:t>✓ Smart Alerts — news and CIO conflicts matched against client DNA
+</a:t>
+            </a:r>
+            <a:pPr indent="0" marL="0">
+              <a:buNone/>
+            </a:pPr>
+            <a:r>
+              <a:rPr lang="en-US" sz="1400" dirty="0">
+                <a:solidFill>
+                  <a:srgbClr val="E2E8F0"/>
+                </a:solidFill>
+              </a:rPr>
+              <a:t>✓ DNA-Aware Swaps — replacements within mandate, BUY-rated by CIO
+</a:t>
+            </a:r>
+            <a:pPr indent="0" marL="0">
+              <a:buNone/>
+            </a:pPr>
+            <a:r>
+              <a:rPr lang="en-US" sz="1400" dirty="0">
+                <a:solidFill>
+                  <a:srgbClr val="E2E8F0"/>
+                </a:solidFill>
+              </a:rPr>
+              <a:t>✓ Tone-Matched Messages — data-driven or values-led, per client
+</a:t>
+            </a:r>
+            <a:pPr indent="0" marL="0">
+              <a:buNone/>
+            </a:pPr>
+            <a:r>
+              <a:rPr lang="en-US" sz="1400" dirty="0">
+                <a:solidFill>
+                  <a:srgbClr val="E2E8F0"/>
+                </a:solidFill>
+              </a:rPr>
+              <a:t>✓ Full Tracing — every AI decision logged with reasoning chain
+</a:t>
+            </a:r>
+            <a:pPr indent="0" marL="0">
+              <a:buNone/>
+            </a:pPr>
+            <a:r>
+              <a:rPr lang="en-US" sz="1400" dirty="0">
+                <a:solidFill>
+                  <a:srgbClr val="E2E8F0"/>
+                </a:solidFill>
+              </a:rPr>
+              <a:t>✓ Human-in-the-Loop — RM approves, client always decides
+</a:t>
+            </a:r>
+            <a:endParaRPr lang="en-US" sz="1400" dirty="0"/>
+          </a:p>
+        </p:txBody>
+      </p:sp>
+    </p:spTree>
+  </p:cSld>
+  <p:clrMapOvr>
+    <a:masterClrMapping/>
+  </p:clrMapOvr>
+</p:sld>
+</file>
+
+<file path=ppt/slides/slide8.xml><?xml version="1.0" encoding="utf-8"?>
+<p:sld xmlns:a="http://schemas.openxmlformats.org/drawingml/2006/main" xmlns:r="http://schemas.openxmlformats.org/officeDocument/2006/relationships" xmlns:p="http://schemas.openxmlformats.org/presentationml/2006/main">
+  <p:cSld name="Slide 8">
+    <p:bg>
+      <p:bgPr>
+        <a:solidFill>
+          <a:srgbClr val="0F172A"/>
+        </a:solidFill>
+      </p:bgPr>
+    </p:bg>
+    <p:spTree>
+      <p:nvGrpSpPr>
+        <p:cNvPr id="1" name=""/>
+        <p:cNvGrpSpPr/>
+        <p:nvPr/>
+      </p:nvGrpSpPr>
+      <p:grpSpPr>
+        <a:xfrm>
+          <a:off x="0" y="0"/>
+          <a:ext cx="0" cy="0"/>
+          <a:chOff x="0" y="0"/>
+          <a:chExt cx="0" cy="0"/>
+        </a:xfrm>
+      </p:grpSpPr>
+      <p:sp>
+        <p:nvSpPr>
+          <p:cNvPr id="2" name="Text 0"/>
+          <p:cNvSpPr/>
+          <p:nvPr/>
+        </p:nvSpPr>
+        <p:spPr>
+          <a:xfrm>
+            <a:off x="457200" y="457200"/>
+            <a:ext cx="8229600" cy="731520"/>
+          </a:xfrm>
+          <a:prstGeom prst="rect">
+            <a:avLst/>
+          </a:prstGeom>
+          <a:noFill/>
+          <a:ln/>
+        </p:spPr>
+        <p:txBody>
+          <a:bodyPr wrap="square" rtlCol="0" anchor="ctr"/>
+          <a:lstStyle/>
+          <a:p>
+            <a:pPr indent="0" marL="0">
+              <a:buNone/>
+            </a:pPr>
+            <a:r>
+              <a:rPr lang="en-US" sz="2800" b="1" dirty="0">
+                <a:solidFill>
+                  <a:srgbClr val="FFFFFF"/>
+                </a:solidFill>
+              </a:rPr>
+              <a:t>Trust &amp; Explainability</a:t>
+            </a:r>
+            <a:endParaRPr lang="en-US" sz="2800" dirty="0"/>
+          </a:p>
+        </p:txBody>
+      </p:sp>
+      <p:sp>
+        <p:nvSpPr>
+          <p:cNvPr id="3" name="Text 1"/>
+          <p:cNvSpPr/>
+          <p:nvPr/>
+        </p:nvSpPr>
+        <p:spPr>
+          <a:xfrm>
+            <a:off x="457200" y="1371600"/>
+            <a:ext cx="8229600" cy="3657600"/>
+          </a:xfrm>
+          <a:prstGeom prst="rect">
+            <a:avLst/>
+          </a:prstGeom>
+          <a:noFill/>
+          <a:ln/>
+        </p:spPr>
+        <p:txBody>
+          <a:bodyPr wrap="square" rtlCol="0" anchor="ctr"/>
+          <a:lstStyle/>
+          <a:p>
+            <a:pPr indent="0" marL="0">
+              <a:buNone/>
+            </a:pPr>
+            <a:r>
+              <a:rPr lang="en-US" sz="1400" b="1" dirty="0">
+                <a:solidFill>
+                  <a:srgbClr val="2DD4BF"/>
+                </a:solidFill>
+              </a:rPr>
+              <a:t>• Source attribution</a:t>
+            </a:r>
+            <a:pPr indent="0" marL="0">
+              <a:buNone/>
+            </a:pPr>
+            <a:r>
+              <a:rPr lang="en-US" sz="1400" dirty="0">
+                <a:solidFill>
+                  <a:srgbClr val="94A3B8"/>
+                </a:solidFill>
+              </a:rPr>
+              <a:t> — every AI output cites the exact data sources used
+</a:t>
+            </a:r>
+            <a:pPr indent="0" marL="0">
+              <a:buNone/>
+            </a:pPr>
+            <a:r>
+              <a:rPr lang="en-US" sz="1400" b="1" dirty="0">
+                <a:solidFill>
+                  <a:srgbClr val="2DD4BF"/>
+                </a:solidFill>
+              </a:rPr>
+              <a:t>• Reasoning chains</a:t>
+            </a:r>
+            <a:pPr indent="0" marL="0">
+              <a:buNone/>
+            </a:pPr>
+            <a:r>
+              <a:rPr lang="en-US" sz="1400" dirty="0">
+                <a:solidFill>
+                  <a:srgbClr val="94A3B8"/>
+                </a:solidFill>
+              </a:rPr>
+              <a:t> — step-by-step logic visible for all decisions and recommendations
+</a:t>
+            </a:r>
+            <a:pPr indent="0" marL="0">
+              <a:buNone/>
+            </a:pPr>
+            <a:r>
+              <a:rPr lang="en-US" sz="1400" b="1" dirty="0">
+                <a:solidFill>
+                  <a:srgbClr val="2DD4BF"/>
+                </a:solidFill>
+              </a:rPr>
+              <a:t>• Audit trail</a:t>
+            </a:r>
+            <a:pPr indent="0" marL="0">
+              <a:buNone/>
+            </a:pPr>
+            <a:r>
+              <a:rPr lang="en-US" sz="1400" dirty="0">
+                <a:solidFill>
+                  <a:srgbClr val="94A3B8"/>
+                </a:solidFill>
+              </a:rPr>
+              <a:t> — immutable timestamped log of every agent action and inference
+</a:t>
+            </a:r>
+            <a:pPr indent="0" marL="0">
+              <a:buNone/>
+            </a:pPr>
+            <a:r>
+              <a:rPr lang="en-US" sz="1400" b="1" dirty="0">
+                <a:solidFill>
+                  <a:srgbClr val="2DD4BF"/>
+                </a:solidFill>
+              </a:rPr>
+              <a:t>• Human-in-the-loop approval</a:t>
+            </a:r>
+            <a:pPr indent="0" marL="0">
+              <a:buNone/>
+            </a:pPr>
+            <a:r>
+              <a:rPr lang="en-US" sz="1400" dirty="0">
+                <a:solidFill>
+                  <a:srgbClr val="94A3B8"/>
+                </a:solidFill>
+              </a:rPr>
+              <a:t> — RM reviews and signs off before anything reaches the client
+</a:t>
+            </a:r>
+            <a:pPr indent="0" marL="0">
+              <a:buNone/>
+            </a:pPr>
+            <a:r>
+              <a:rPr lang="en-US" sz="1400" b="1" dirty="0">
+                <a:solidFill>
+                  <a:srgbClr val="2DD4BF"/>
+                </a:solidFill>
+              </a:rPr>
+              <a:t>• Confidence scores</a:t>
+            </a:r>
+            <a:pPr indent="0" marL="0">
+              <a:buNone/>
+            </a:pPr>
+            <a:r>
+              <a:rPr lang="en-US" sz="1400" dirty="0">
+                <a:solidFill>
+                  <a:srgbClr val="94A3B8"/>
+                </a:solidFill>
+              </a:rPr>
+              <a:t> — calibrated certainty indicators on all AI outputs
+</a:t>
+            </a:r>
+            <a:pPr indent="0" marL="0">
+              <a:buNone/>
+            </a:pPr>
+            <a:r>
+              <a:rPr lang="en-US" sz="1400" b="1" dirty="0">
+                <a:solidFill>
+                  <a:srgbClr val="2DD4BF"/>
+                </a:solidFill>
+              </a:rPr>
+              <a:t>• Agent execution tracing</a:t>
+            </a:r>
+            <a:pPr indent="0" marL="0">
+              <a:buNone/>
+            </a:pPr>
+            <a:r>
+              <a:rPr lang="en-US" sz="1400" dirty="0">
+                <a:solidFill>
+                  <a:srgbClr val="94A3B8"/>
+                </a:solidFill>
+              </a:rPr>
+              <a:t> — full visibility into which agent ran, when, and why
+</a:t>
+            </a:r>
+            <a:endParaRPr lang="en-US" sz="1400" dirty="0"/>
+          </a:p>
+        </p:txBody>
+      </p:sp>
+    </p:spTree>
+  </p:cSld>
+  <p:clrMapOvr>
+    <a:masterClrMapping/>
+  </p:clrMapOvr>
+</p:sld>
+</file>
+
+<file path=ppt/slides/slide9.xml><?xml version="1.0" encoding="utf-8"?>
+<p:sld xmlns:a="http://schemas.openxmlformats.org/drawingml/2006/main" xmlns:r="http://schemas.openxmlformats.org/officeDocument/2006/relationships" xmlns:p="http://schemas.openxmlformats.org/presentationml/2006/main">
+  <p:cSld name="Slide 9">
+    <p:bg>
+      <p:bgPr>
+        <a:solidFill>
+          <a:srgbClr val="0F172A"/>
+        </a:solidFill>
+      </p:bgPr>
+    </p:bg>
+    <p:spTree>
+      <p:nvGrpSpPr>
+        <p:cNvPr id="1" name=""/>
+        <p:cNvGrpSpPr/>
+        <p:nvPr/>
+      </p:nvGrpSpPr>
+      <p:grpSpPr>
+        <a:xfrm>
+          <a:off x="0" y="0"/>
+          <a:ext cx="0" cy="0"/>
+          <a:chOff x="0" y="0"/>
+          <a:chExt cx="0" cy="0"/>
+        </a:xfrm>
+      </p:grpSpPr>
+      <p:sp>
+        <p:nvSpPr>
+          <p:cNvPr id="2" name="Text 0"/>
+          <p:cNvSpPr/>
+          <p:nvPr/>
+        </p:nvSpPr>
+        <p:spPr>
+          <a:xfrm>
+            <a:off x="457200" y="457200"/>
+            <a:ext cx="8229600" cy="731520"/>
+          </a:xfrm>
+          <a:prstGeom prst="rect">
+            <a:avLst/>
+          </a:prstGeom>
+          <a:noFill/>
+          <a:ln/>
+        </p:spPr>
+        <p:txBody>
+          <a:bodyPr wrap="square" rtlCol="0" anchor="ctr"/>
+          <a:lstStyle/>
+          <a:p>
+            <a:pPr indent="0" marL="0">
+              <a:buNone/>
+            </a:pPr>
+            <a:r>
+              <a:rPr lang="en-US" sz="2800" b="1" dirty="0">
+                <a:solidFill>
+                  <a:srgbClr val="FFFFFF"/>
+                </a:solidFill>
+              </a:rPr>
+              <a:t>Four Client Personas</a:t>
+            </a:r>
+            <a:endParaRPr lang="en-US" sz="2800" dirty="0"/>
+          </a:p>
+        </p:txBody>
+      </p:sp>
+      <p:sp>
+        <p:nvSpPr>
+          <p:cNvPr id="3" name="Text 1"/>
+          <p:cNvSpPr/>
+          <p:nvPr/>
+        </p:nvSpPr>
+        <p:spPr>
+          <a:xfrm>
+            <a:off x="457200" y="1371600"/>
+            <a:ext cx="8229600" cy="3657600"/>
+          </a:xfrm>
+          <a:prstGeom prst="rect">
+            <a:avLst/>
+          </a:prstGeom>
+          <a:noFill/>
+          <a:ln/>
+        </p:spPr>
+        <p:txBody>
+          <a:bodyPr wrap="square" rtlCol="0" anchor="ctr"/>
+          <a:lstStyle/>
+          <a:p>
+            <a:pPr indent="0" marL="0">
+              <a:buNone/>
+            </a:pPr>
+            <a:r>
+              <a:rPr lang="en-US" sz="1400" b="1" dirty="0">
+                <a:solidFill>
+                  <a:srgbClr val="2DD4BF"/>
+                </a:solidFill>
+              </a:rPr>
+              <a:t>• Schneider</a:t>
+            </a:r>
+            <a:pPr indent="0" marL="0">
+              <a:buNone/>
+            </a:pPr>
+            <a:r>
+              <a:rPr lang="en-US" sz="1400" dirty="0">
+                <a:solidFill>
+                  <a:srgbClr val="94A3B8"/>
+                </a:solidFill>
+              </a:rPr>
+              <a:t> — family foundation, values-led: ESG screening applied across the full portfolio
+</a:t>
+            </a:r>
+            <a:pPr indent="0" marL="0">
+              <a:buNone/>
+            </a:pPr>
+            <a:r>
+              <a:rPr lang="en-US" sz="1400" b="1" dirty="0">
+                <a:solidFill>
+                  <a:srgbClr val="2DD4BF"/>
+                </a:solidFill>
+              </a:rPr>
+              <a:t>• Huber</a:t>
+            </a:r>
+            <a:pPr indent="0" marL="0">
+              <a:buNone/>
+            </a:pPr>
+            <a:r>
+              <a:rPr lang="en-US" sz="1400" dirty="0">
+                <a:solidFill>
+                  <a:srgbClr val="94A3B8"/>
+                </a:solidFill>
+              </a:rPr>
+              <a:t> — environmentalist, sustainability: impact holdings prioritised, carbon intensity flagged
+</a:t>
+            </a:r>
+            <a:pPr indent="0" marL="0">
+              <a:buNone/>
+            </a:pPr>
+            <a:r>
+              <a:rPr lang="en-US" sz="1400" b="1" dirty="0">
+                <a:solidFill>
+                  <a:srgbClr val="2DD4BF"/>
+                </a:solidFill>
+              </a:rPr>
+              <a:t>• Räber</a:t>
+            </a:r>
+            <a:pPr indent="0" marL="0">
+              <a:buNone/>
+            </a:pPr>
+            <a:r>
+              <a:rPr lang="en-US" sz="1400" dirty="0">
+                <a:solidFill>
+                  <a:srgbClr val="94A3B8"/>
+                </a:solidFill>
+              </a:rPr>
+              <a:t> — conservative, data-driven: quantitative rationale, low-volatility mandates enforced
+</a:t>
+            </a:r>
+            <a:pPr indent="0" marL="0">
+              <a:buNone/>
+            </a:pPr>
+            <a:r>
+              <a:rPr lang="en-US" sz="1400" b="1" dirty="0">
+                <a:solidFill>
+                  <a:srgbClr val="2DD4BF"/>
+                </a:solidFill>
+              </a:rPr>
+              <a:t>• Ammann</a:t>
+            </a:r>
+            <a:pPr indent="0" marL="0">
+              <a:buNone/>
+            </a:pPr>
+            <a:r>
+              <a:rPr lang="en-US" sz="1400" dirty="0">
+                <a:solidFill>
+                  <a:srgbClr val="94A3B8"/>
+                </a:solidFill>
+              </a:rPr>
+              <a:t> — entrepreneur, reputational risk: exposure to sector controversies monitored in real time
+</a:t>
+            </a:r>
+            <a:endParaRPr lang="en-US" sz="1400" dirty="0"/>
           </a:p>
         </p:txBody>
       </p:sp>

</xml_diff>